<commit_message>
2024 update end semester
</commit_message>
<xml_diff>
--- a/lecture-slides_upload/lecture/12_Statistical Methods_Chi-Square and Loglinear Analysis.pptx
+++ b/lecture-slides_upload/lecture/12_Statistical Methods_Chi-Square and Loglinear Analysis.pptx
@@ -222,7 +222,7 @@
           <a:p>
             <a:fld id="{6A4B1ABF-BAF2-0E4B-88A8-8F2BBF0074AC}" type="datetimeFigureOut">
               <a:rPr lang="en-US" smtClean="0"/>
-              <a:t>11/16/21</a:t>
+              <a:t>4/24/24</a:t>
             </a:fld>
             <a:endParaRPr lang="en-US"/>
           </a:p>
@@ -1181,7 +1181,7 @@
           <a:p>
             <a:fld id="{BA763BF8-AC66-E249-9CE8-8353EEB16B82}" type="datetimeFigureOut">
               <a:rPr lang="en-US" smtClean="0"/>
-              <a:t>11/16/21</a:t>
+              <a:t>4/24/24</a:t>
             </a:fld>
             <a:endParaRPr lang="en-US"/>
           </a:p>
@@ -1383,7 +1383,7 @@
           <a:p>
             <a:fld id="{BA763BF8-AC66-E249-9CE8-8353EEB16B82}" type="datetimeFigureOut">
               <a:rPr lang="en-US" smtClean="0"/>
-              <a:t>11/16/21</a:t>
+              <a:t>4/24/24</a:t>
             </a:fld>
             <a:endParaRPr lang="en-US"/>
           </a:p>
@@ -1591,7 +1591,7 @@
           <a:p>
             <a:fld id="{BA763BF8-AC66-E249-9CE8-8353EEB16B82}" type="datetimeFigureOut">
               <a:rPr lang="en-US" smtClean="0"/>
-              <a:t>11/16/21</a:t>
+              <a:t>4/24/24</a:t>
             </a:fld>
             <a:endParaRPr lang="en-US"/>
           </a:p>
@@ -1793,7 +1793,7 @@
           <a:p>
             <a:fld id="{BA763BF8-AC66-E249-9CE8-8353EEB16B82}" type="datetimeFigureOut">
               <a:rPr lang="en-US" smtClean="0"/>
-              <a:t>11/16/21</a:t>
+              <a:t>4/24/24</a:t>
             </a:fld>
             <a:endParaRPr lang="en-US"/>
           </a:p>
@@ -2068,7 +2068,7 @@
           <a:p>
             <a:fld id="{BA763BF8-AC66-E249-9CE8-8353EEB16B82}" type="datetimeFigureOut">
               <a:rPr lang="en-US" smtClean="0"/>
-              <a:t>11/16/21</a:t>
+              <a:t>4/24/24</a:t>
             </a:fld>
             <a:endParaRPr lang="en-US"/>
           </a:p>
@@ -2337,7 +2337,7 @@
           <a:p>
             <a:fld id="{BA763BF8-AC66-E249-9CE8-8353EEB16B82}" type="datetimeFigureOut">
               <a:rPr lang="en-US" smtClean="0"/>
-              <a:t>11/16/21</a:t>
+              <a:t>4/24/24</a:t>
             </a:fld>
             <a:endParaRPr lang="en-US"/>
           </a:p>
@@ -2753,7 +2753,7 @@
           <a:p>
             <a:fld id="{BA763BF8-AC66-E249-9CE8-8353EEB16B82}" type="datetimeFigureOut">
               <a:rPr lang="en-US" smtClean="0"/>
-              <a:t>11/16/21</a:t>
+              <a:t>4/24/24</a:t>
             </a:fld>
             <a:endParaRPr lang="en-US"/>
           </a:p>
@@ -2898,7 +2898,7 @@
           <a:p>
             <a:fld id="{BA763BF8-AC66-E249-9CE8-8353EEB16B82}" type="datetimeFigureOut">
               <a:rPr lang="en-US" smtClean="0"/>
-              <a:t>11/16/21</a:t>
+              <a:t>4/24/24</a:t>
             </a:fld>
             <a:endParaRPr lang="en-US"/>
           </a:p>
@@ -3011,7 +3011,7 @@
           <a:p>
             <a:fld id="{BA763BF8-AC66-E249-9CE8-8353EEB16B82}" type="datetimeFigureOut">
               <a:rPr lang="en-US" smtClean="0"/>
-              <a:t>11/16/21</a:t>
+              <a:t>4/24/24</a:t>
             </a:fld>
             <a:endParaRPr lang="en-US"/>
           </a:p>
@@ -3322,7 +3322,7 @@
           <a:p>
             <a:fld id="{BA763BF8-AC66-E249-9CE8-8353EEB16B82}" type="datetimeFigureOut">
               <a:rPr lang="en-US" smtClean="0"/>
-              <a:t>11/16/21</a:t>
+              <a:t>4/24/24</a:t>
             </a:fld>
             <a:endParaRPr lang="en-US"/>
           </a:p>
@@ -3610,7 +3610,7 @@
           <a:p>
             <a:fld id="{BA763BF8-AC66-E249-9CE8-8353EEB16B82}" type="datetimeFigureOut">
               <a:rPr lang="en-US" smtClean="0"/>
-              <a:t>11/16/21</a:t>
+              <a:t>4/24/24</a:t>
             </a:fld>
             <a:endParaRPr lang="en-US"/>
           </a:p>
@@ -3854,7 +3854,7 @@
             <a:fld id="{BA763BF8-AC66-E249-9CE8-8353EEB16B82}" type="datetimeFigureOut">
               <a:rPr lang="en-US" smtClean="0"/>
               <a:pPr/>
-              <a:t>11/16/21</a:t>
+              <a:t>4/24/24</a:t>
             </a:fld>
             <a:endParaRPr lang="en-US"/>
           </a:p>
@@ -4325,14 +4325,6 @@
           <a:bodyPr/>
           <a:lstStyle/>
           <a:p>
-            <a:r>
-              <a:rPr lang="en-GB" dirty="0"/>
-              <a:t>Vanessa </a:t>
-            </a:r>
-            <a:r>
-              <a:rPr lang="en-GB" dirty="0" err="1"/>
-              <a:t>LoBue</a:t>
-            </a:r>
             <a:endParaRPr lang="en-GB" dirty="0"/>
           </a:p>
           <a:p>
@@ -4349,7 +4341,15 @@
           <a:p>
             <a:r>
               <a:rPr lang="en-GB" dirty="0"/>
-              <a:t>with a little help from Andy Field</a:t>
+              <a:t>with help from Vanessa </a:t>
+            </a:r>
+            <a:r>
+              <a:rPr lang="en-GB" dirty="0" err="1"/>
+              <a:t>Lobue</a:t>
+            </a:r>
+            <a:r>
+              <a:rPr lang="en-GB" dirty="0"/>
+              <a:t> and Andy Field</a:t>
             </a:r>
           </a:p>
         </p:txBody>
@@ -7536,7 +7536,7 @@
           <a:p>
             <a:r>
               <a:rPr lang="en-GB" dirty="0"/>
-              <a:t>An Example: Dancing Cats and Dogs</a:t>
+              <a:t>An Example: Dancing Cats</a:t>
             </a:r>
           </a:p>
         </p:txBody>
@@ -8176,7 +8176,7 @@
             <a:pPr lvl="1"/>
             <a:r>
               <a:rPr lang="en-US" dirty="0"/>
-              <a:t>I represents the rows in the contingency table and j represents the columns.</a:t>
+              <a:t>i represents the rows in the contingency table and j represents the columns.</a:t>
             </a:r>
           </a:p>
           <a:p>
@@ -8550,14 +8550,37 @@
             <a:pPr lvl="1"/>
             <a:r>
               <a:rPr lang="en-US" dirty="0"/>
-              <a:t>Checked against a distribution with (r − 1)(c − 1) degrees of freedom.</a:t>
-            </a:r>
+              <a:t>The distribution of the	       statistic under the null is known, based on </a:t>
+            </a:r>
+            <a:r>
+              <a:rPr lang="en-US" dirty="0" err="1"/>
+              <a:t>df</a:t>
+            </a:r>
+            <a:endParaRPr lang="en-US" dirty="0"/>
           </a:p>
           <a:p>
             <a:pPr lvl="1"/>
             <a:r>
+              <a:rPr lang="en-US" dirty="0" err="1"/>
+              <a:t>Df</a:t>
+            </a:r>
+            <a:r>
               <a:rPr lang="en-US" dirty="0"/>
-              <a:t>If significant then there is a significant association between the categorical variables in the population.</a:t>
+              <a:t> = (r − 1)(c − 1)</a:t>
+            </a:r>
+          </a:p>
+          <a:p>
+            <a:pPr lvl="1"/>
+            <a:r>
+              <a:rPr lang="en-US" dirty="0"/>
+              <a:t>If the probability of the      is lower than alpha (often .05) then the null hypothesis of no association between the categorical variables is rejected (i.e., there is a significant association between the variables).</a:t>
+            </a:r>
+          </a:p>
+          <a:p>
+            <a:pPr lvl="2"/>
+            <a:r>
+              <a:rPr lang="en-US" dirty="0"/>
+              <a:t>E.g., reward type is significantly associated with dancing</a:t>
             </a:r>
           </a:p>
         </p:txBody>
@@ -8579,6 +8602,74 @@
           <a:xfrm>
             <a:off x="3773347" y="3048487"/>
             <a:ext cx="5410200" cy="761026"/>
+          </a:xfrm>
+          <a:prstGeom prst="rect">
+            <a:avLst/>
+          </a:prstGeom>
+          <a:noFill/>
+          <a:ln w="9525">
+            <a:noFill/>
+            <a:miter lim="800000"/>
+            <a:headEnd/>
+            <a:tailEnd/>
+          </a:ln>
+        </p:spPr>
+      </p:pic>
+      <p:pic>
+        <p:nvPicPr>
+          <p:cNvPr id="2" name="Picture 1">
+            <a:extLst>
+              <a:ext uri="{FF2B5EF4-FFF2-40B4-BE49-F238E27FC236}">
+                <a16:creationId xmlns:a16="http://schemas.microsoft.com/office/drawing/2014/main" id="{AAB402E6-13D6-F3EB-5083-1D25A5513EC8}"/>
+              </a:ext>
+            </a:extLst>
+          </p:cNvPr>
+          <p:cNvPicPr/>
+          <p:nvPr/>
+        </p:nvPicPr>
+        <p:blipFill rotWithShape="1">
+          <a:blip r:embed="rId4"/>
+          <a:srcRect l="1832" t="29449" r="88504" b="24974"/>
+          <a:stretch/>
+        </p:blipFill>
+        <p:spPr bwMode="auto">
+          <a:xfrm>
+            <a:off x="4491804" y="4091780"/>
+            <a:ext cx="424543" cy="604157"/>
+          </a:xfrm>
+          <a:prstGeom prst="rect">
+            <a:avLst/>
+          </a:prstGeom>
+          <a:noFill/>
+          <a:ln w="9525">
+            <a:noFill/>
+            <a:miter lim="800000"/>
+            <a:headEnd/>
+            <a:tailEnd/>
+          </a:ln>
+        </p:spPr>
+      </p:pic>
+      <p:pic>
+        <p:nvPicPr>
+          <p:cNvPr id="3" name="Picture 2">
+            <a:extLst>
+              <a:ext uri="{FF2B5EF4-FFF2-40B4-BE49-F238E27FC236}">
+                <a16:creationId xmlns:a16="http://schemas.microsoft.com/office/drawing/2014/main" id="{34C1965C-857F-AEE7-BF26-42BB388B47E0}"/>
+              </a:ext>
+            </a:extLst>
+          </p:cNvPr>
+          <p:cNvPicPr/>
+          <p:nvPr/>
+        </p:nvPicPr>
+        <p:blipFill rotWithShape="1">
+          <a:blip r:embed="rId4"/>
+          <a:srcRect l="1832" t="29449" r="88504" b="24974"/>
+          <a:stretch/>
+        </p:blipFill>
+        <p:spPr bwMode="auto">
+          <a:xfrm>
+            <a:off x="4491803" y="4865233"/>
+            <a:ext cx="424543" cy="604157"/>
           </a:xfrm>
           <a:prstGeom prst="rect">
             <a:avLst/>
@@ -8826,6 +8917,68 @@
                                   </p:childTnLst>
                                 </p:cTn>
                               </p:par>
+                              <p:par>
+                                <p:cTn id="19" presetID="1" presetClass="entr" presetSubtype="0" fill="hold" grpId="0" nodeType="withEffect">
+                                  <p:stCondLst>
+                                    <p:cond delay="0"/>
+                                  </p:stCondLst>
+                                  <p:childTnLst>
+                                    <p:set>
+                                      <p:cBhvr>
+                                        <p:cTn id="20" dur="1" fill="hold">
+                                          <p:stCondLst>
+                                            <p:cond delay="0"/>
+                                          </p:stCondLst>
+                                        </p:cTn>
+                                        <p:tgtEl>
+                                          <p:spTgt spid="5">
+                                            <p:txEl>
+                                              <p:pRg st="8" end="8"/>
+                                            </p:txEl>
+                                          </p:spTgt>
+                                        </p:tgtEl>
+                                        <p:attrNameLst>
+                                          <p:attrName>style.visibility</p:attrName>
+                                        </p:attrNameLst>
+                                      </p:cBhvr>
+                                      <p:to>
+                                        <p:strVal val="visible"/>
+                                      </p:to>
+                                    </p:set>
+                                  </p:childTnLst>
+                                </p:cTn>
+                              </p:par>
+                              <p:par>
+                                <p:cTn id="21" presetID="1" presetClass="entr" presetSubtype="0" fill="hold" grpId="0" nodeType="withEffect">
+                                  <p:stCondLst>
+                                    <p:cond delay="0"/>
+                                  </p:stCondLst>
+                                  <p:childTnLst>
+                                    <p:set>
+                                      <p:cBhvr>
+                                        <p:cTn id="22" dur="1" fill="hold">
+                                          <p:stCondLst>
+                                            <p:cond delay="0"/>
+                                          </p:stCondLst>
+                                        </p:cTn>
+                                        <p:tgtEl>
+                                          <p:spTgt spid="5">
+                                            <p:txEl>
+                                              <p:pRg st="9" end="9"/>
+                                            </p:txEl>
+                                          </p:spTgt>
+                                        </p:tgtEl>
+                                        <p:attrNameLst>
+                                          <p:attrName>style.visibility</p:attrName>
+                                        </p:attrNameLst>
+                                      </p:cBhvr>
+                                      <p:to>
+                                        <p:strVal val="visible"/>
+                                      </p:to>
+                                    </p:set>
+                                  </p:childTnLst>
+                                </p:cTn>
+                              </p:par>
                             </p:childTnLst>
                           </p:cTn>
                         </p:par>
@@ -8927,20 +9080,25 @@
           <a:p>
             <a:r>
               <a:rPr lang="en-US" dirty="0"/>
-              <a:t>Looks for associations between three or more categorical variables</a:t>
+              <a:t>For associations between three or more categorical variables</a:t>
             </a:r>
           </a:p>
           <a:p>
             <a:r>
               <a:rPr lang="en-US" dirty="0"/>
-              <a:t>Example: Dancing Dogs</a:t>
-            </a:r>
+              <a:t>Example: Dancing </a:t>
+            </a:r>
+            <a:r>
+              <a:rPr lang="en-US"/>
+              <a:t>Cats and Dogs</a:t>
+            </a:r>
+            <a:endParaRPr lang="en-US" dirty="0"/>
           </a:p>
           <a:p>
             <a:pPr lvl="1"/>
             <a:r>
               <a:rPr lang="en-US" dirty="0"/>
-              <a:t>Same example as before but with data from 70 dogs.</a:t>
+              <a:t>Same example as before but add data from 70 dogs.</a:t>
             </a:r>
           </a:p>
           <a:p>

</xml_diff>